<commit_message>
fix(thesis): consolidate chapter structure (IMP-C1)
- strip duplicate Ch II content from chapter1_introduction.md
- fold methodology (former Ch III) into Ch IV §§ 4.5-4.10
- remove disclaimer + dual Ch headings from literature review file
- rename chapter files to zero-padded chapterNN_<slug>.md pattern
  matching declared chapter numbers
- update build_thesis_docx.py for new filenames
- delete superseded chapter3_methodology.md

Resolves audit finding RI-1 / IMP-C1.
</commit_message>
<xml_diff>
--- a/thesis/health_rl/health_rl_defense_presentation.pptx
+++ b/thesis/health_rl/health_rl_defense_presentation.pptx
@@ -3585,7 +3585,7 @@
                           </a:solidFill>
                           <a:latin typeface="Calibri"/>
                         </a:rPr>
-                        <a:t>$58,642</a:t>
+                        <a:t>$90,540</a:t>
                       </a:r>
                     </a:p>
                   </a:txBody>
@@ -3603,7 +3603,7 @@
                           </a:solidFill>
                           <a:latin typeface="Calibri"/>
                         </a:rPr>
-                        <a:t>$35,032</a:t>
+                        <a:t>$72,292</a:t>
                       </a:r>
                     </a:p>
                   </a:txBody>
@@ -3621,7 +3621,7 @@
                           </a:solidFill>
                           <a:latin typeface="Calibri"/>
                         </a:rPr>
-                        <a:t>+$23,610 (+67%)</a:t>
+                        <a:t>+$18,248 (+25%) ***</a:t>
                       </a:r>
                     </a:p>
                   </a:txBody>
@@ -3663,7 +3663,7 @@
                           </a:solidFill>
                           <a:latin typeface="Calibri"/>
                         </a:rPr>
-                        <a:t>$5.35</a:t>
+                        <a:t>$2.20</a:t>
                       </a:r>
                     </a:p>
                   </a:txBody>
@@ -3685,7 +3685,7 @@
                           </a:solidFill>
                           <a:latin typeface="Calibri"/>
                         </a:rPr>
-                        <a:t>$10.66</a:t>
+                        <a:t>$9.01</a:t>
                       </a:r>
                     </a:p>
                   </a:txBody>
@@ -3707,7 +3707,7 @@
                           </a:solidFill>
                           <a:latin typeface="Calibri"/>
                         </a:rPr>
-                        <a:t>-$5.31 (-50%)</a:t>
+                        <a:t>-$6.81 (-76%) ***</a:t>
                       </a:r>
                     </a:p>
                   </a:txBody>
@@ -3749,7 +3749,7 @@
                           </a:solidFill>
                           <a:latin typeface="Calibri"/>
                         </a:rPr>
-                        <a:t>1.382</a:t>
+                        <a:t>1.314</a:t>
                       </a:r>
                     </a:p>
                   </a:txBody>
@@ -3785,7 +3785,7 @@
                           </a:solidFill>
                           <a:latin typeface="Calibri"/>
                         </a:rPr>
-                        <a:t>Uniform exploration</a:t>
+                        <a:t>Near-uniform exploration</a:t>
                       </a:r>
                     </a:p>
                   </a:txBody>
@@ -3827,7 +3827,7 @@
                           </a:solidFill>
                           <a:latin typeface="Calibri"/>
                         </a:rPr>
-                        <a:t>1.215</a:t>
+                        <a:t>1.105</a:t>
                       </a:r>
                     </a:p>
                   </a:txBody>
@@ -3871,7 +3871,7 @@
                           </a:solidFill>
                           <a:latin typeface="Calibri"/>
                         </a:rPr>
-                        <a:t>Concentrated exploitation</a:t>
+                        <a:t>Exploitation regime</a:t>
                       </a:r>
                     </a:p>
                   </a:txBody>
@@ -3974,7 +3974,7 @@
                 </a:solidFill>
                 <a:latin typeface="Calibri"/>
               </a:rPr>
-              <a:t>-  LinUCB cumulative reward exceeds static baseline - PASS</a:t>
+              <a:t>-  LinUCB reward &gt; Static XGB by +$18,248 (Wilcoxon p&lt;0.001, Cohen's d=2.98) - PASS</a:t>
             </a:r>
           </a:p>
           <a:p>
@@ -3985,7 +3985,7 @@
                 </a:solidFill>
                 <a:latin typeface="Calibri"/>
               </a:rPr>
-              <a:t>-  Average regret in final 500 rounds is lower - PASS</a:t>
+              <a:t>-  Late-round regret 4x lower (Wilcoxon p&lt;0.001, d=-1.59) - PASS</a:t>
             </a:r>
           </a:p>
           <a:p>
@@ -3996,7 +3996,7 @@
                 </a:solidFill>
                 <a:latin typeface="Calibri"/>
               </a:rPr>
-              <a:t>-  Action entropy decreased: exploration converged to exploitation - PASS</a:t>
+              <a:t>-  Action entropy decreased: 1.314 -&gt; 1.105 (exploration -&gt; exploitation) - PASS</a:t>
             </a:r>
           </a:p>
           <a:p>
@@ -4007,7 +4007,7 @@
                 </a:solidFill>
                 <a:latin typeface="Calibri"/>
               </a:rPr>
-              <a:t>-  STANDARD share rose from 28% to 42%; REFER fell from 24% to 9%</a:t>
+              <a:t>-  20-seed bootstrap CIs reported throughout; no single-seed cherry-picking</a:t>
             </a:r>
           </a:p>
         </p:txBody>
@@ -4454,7 +4454,7 @@
                           </a:solidFill>
                           <a:latin typeface="Calibri"/>
                         </a:rPr>
-                        <a:t>PSI</a:t>
+                        <a:t>Max PSI (sliding-window)</a:t>
                       </a:r>
                     </a:p>
                   </a:txBody>
@@ -4476,7 +4476,7 @@
                           </a:solidFill>
                           <a:latin typeface="Calibri"/>
                         </a:rPr>
-                        <a:t>Status</a:t>
+                        <a:t>Final PSI</a:t>
                       </a:r>
                     </a:p>
                   </a:txBody>
@@ -4498,7 +4498,7 @@
                           </a:solidFill>
                           <a:latin typeface="Calibri"/>
                         </a:rPr>
-                        <a:t>Threshold</a:t>
+                        <a:t>Parity Ratio</a:t>
                       </a:r>
                     </a:p>
                   </a:txBody>
@@ -4522,7 +4522,7 @@
                           </a:solidFill>
                           <a:latin typeface="Calibri"/>
                         </a:rPr>
-                        <a:t>Region (full vs approved)</a:t>
+                        <a:t>Region</a:t>
                       </a:r>
                     </a:p>
                   </a:txBody>
@@ -4540,7 +4540,7 @@
                           </a:solidFill>
                           <a:latin typeface="Calibri"/>
                         </a:rPr>
-                        <a:t>0.0057</a:t>
+                        <a:t>0.082 (GREEN)</a:t>
                       </a:r>
                     </a:p>
                   </a:txBody>
@@ -4558,7 +4558,7 @@
                           </a:solidFill>
                           <a:latin typeface="Calibri"/>
                         </a:rPr>
-                        <a:t>GREEN</a:t>
+                        <a:t>0.042 (GREEN)</a:t>
                       </a:r>
                     </a:p>
                   </a:txBody>
@@ -4576,7 +4576,7 @@
                           </a:solidFill>
                           <a:latin typeface="Calibri"/>
                         </a:rPr>
-                        <a:t>&lt; 0.10</a:t>
+                        <a:t>85.7% PASS</a:t>
                       </a:r>
                     </a:p>
                   </a:txBody>
@@ -4596,7 +4596,7 @@
                           </a:solidFill>
                           <a:latin typeface="Calibri"/>
                         </a:rPr>
-                        <a:t>Occupation (full vs approved)</a:t>
+                        <a:t>Occupation</a:t>
                       </a:r>
                     </a:p>
                   </a:txBody>
@@ -4618,7 +4618,7 @@
                           </a:solidFill>
                           <a:latin typeface="Calibri"/>
                         </a:rPr>
-                        <a:t>0.0095</a:t>
+                        <a:t>0.123 (low AMBER)</a:t>
                       </a:r>
                     </a:p>
                   </a:txBody>
@@ -4640,7 +4640,7 @@
                           </a:solidFill>
                           <a:latin typeface="Calibri"/>
                         </a:rPr>
-                        <a:t>GREEN</a:t>
+                        <a:t>0.071 (GREEN)</a:t>
                       </a:r>
                     </a:p>
                   </a:txBody>
@@ -4662,7 +4662,7 @@
                           </a:solidFill>
                           <a:latin typeface="Calibri"/>
                         </a:rPr>
-                        <a:t>&lt; 0.10</a:t>
+                        <a:t>90.1% PASS</a:t>
                       </a:r>
                     </a:p>
                   </a:txBody>
@@ -4707,7 +4707,7 @@
                 </a:solidFill>
                 <a:latin typeface="Calibri"/>
               </a:rPr>
-              <a:t>Fairness Constraint</a:t>
+              <a:t>Fairness Constraint (EEOC 4/5 Rule)</a:t>
             </a:r>
           </a:p>
         </p:txBody>
@@ -4741,7 +4741,7 @@
                 </a:solidFill>
                 <a:latin typeface="Calibri"/>
               </a:rPr>
-              <a:t>-  Min approval rate &gt;= 50% of max rate</a:t>
+              <a:t>-  Min/max approval ratio &gt;= 80%</a:t>
             </a:r>
           </a:p>
           <a:p>
@@ -4752,7 +4752,7 @@
                 </a:solidFill>
                 <a:latin typeface="Calibri"/>
               </a:rPr>
-              <a:t>-  All 6 regions: PASS</a:t>
+              <a:t>-  Region 85.7%: PASS</a:t>
             </a:r>
           </a:p>
           <a:p>
@@ -4763,7 +4763,7 @@
                 </a:solidFill>
                 <a:latin typeface="Calibri"/>
               </a:rPr>
-              <a:t>-  All 7 occupations: PASS</a:t>
+              <a:t>-  Occupation 90.1%: PASS</a:t>
             </a:r>
           </a:p>
         </p:txBody>
@@ -5048,7 +5048,7 @@
                           </a:solidFill>
                           <a:latin typeface="Calibri"/>
                         </a:rPr>
-                        <a:t>$62,000</a:t>
+                        <a:t>$93,572</a:t>
                       </a:r>
                     </a:p>
                   </a:txBody>
@@ -5066,7 +5066,7 @@
                           </a:solidFill>
                           <a:latin typeface="Calibri"/>
                         </a:rPr>
-                        <a:t>$5,641</a:t>
+                        <a:t>$21,149</a:t>
                       </a:r>
                     </a:p>
                   </a:txBody>
@@ -5126,7 +5126,7 @@
                           </a:solidFill>
                           <a:latin typeface="Calibri"/>
                         </a:rPr>
-                        <a:t>$58,642</a:t>
+                        <a:t>$91,947</a:t>
                       </a:r>
                     </a:p>
                   </a:txBody>
@@ -5148,7 +5148,7 @@
                           </a:solidFill>
                           <a:latin typeface="Calibri"/>
                         </a:rPr>
-                        <a:t>$12,954</a:t>
+                        <a:t>$22,774</a:t>
                       </a:r>
                     </a:p>
                   </a:txBody>
@@ -5170,7 +5170,7 @@
                           </a:solidFill>
                           <a:latin typeface="Calibri"/>
                         </a:rPr>
-                        <a:t>2nd</a:t>
+                        <a:t>2nd (tied)</a:t>
                       </a:r>
                     </a:p>
                   </a:txBody>
@@ -5212,7 +5212,7 @@
                           </a:solidFill>
                           <a:latin typeface="Calibri"/>
                         </a:rPr>
-                        <a:t>$45,000</a:t>
+                        <a:t>$76,441</a:t>
                       </a:r>
                     </a:p>
                   </a:txBody>
@@ -5230,7 +5230,7 @@
                           </a:solidFill>
                           <a:latin typeface="Calibri"/>
                         </a:rPr>
-                        <a:t>$24,273</a:t>
+                        <a:t>$38,281</a:t>
                       </a:r>
                     </a:p>
                   </a:txBody>
@@ -5290,7 +5290,7 @@
                           </a:solidFill>
                           <a:latin typeface="Calibri"/>
                         </a:rPr>
-                        <a:t>$35,032</a:t>
+                        <a:t>$72,173</a:t>
                       </a:r>
                     </a:p>
                   </a:txBody>
@@ -5312,7 +5312,7 @@
                           </a:solidFill>
                           <a:latin typeface="Calibri"/>
                         </a:rPr>
-                        <a:t>$35,067</a:t>
+                        <a:t>$42,548</a:t>
                       </a:r>
                     </a:p>
                   </a:txBody>
@@ -5379,7 +5379,7 @@
                 </a:solidFill>
                 <a:latin typeface="Calibri"/>
               </a:rPr>
-              <a:t>PASS Criteria</a:t>
+              <a:t>PASS Criteria (Bonferroni-corrected)</a:t>
             </a:r>
           </a:p>
         </p:txBody>
@@ -5413,7 +5413,7 @@
                 </a:solidFill>
                 <a:latin typeface="Calibri"/>
               </a:rPr>
-              <a:t>-  LinUCB regret &lt; Epsilon-Greedy AND StaticXGB - PASS</a:t>
+              <a:t>-  LinUCB regret &lt;&lt; EpsGreedy and StaticXGB (p&lt;0.001, d=-3.4) - PASS</a:t>
             </a:r>
           </a:p>
           <a:p>
@@ -5424,7 +5424,7 @@
                 </a:solidFill>
                 <a:latin typeface="Calibri"/>
               </a:rPr>
-              <a:t>-  LinTS regret &lt; Epsilon-Greedy AND StaticXGB - PASS</a:t>
+              <a:t>-  LinTS regret &lt;&lt; EpsGreedy and StaticXGB (p&lt;0.001, d=-3.9) - PASS</a:t>
             </a:r>
           </a:p>
           <a:p>
@@ -5435,7 +5435,7 @@
                 </a:solidFill>
                 <a:latin typeface="Calibri"/>
               </a:rPr>
-              <a:t>-  LinUCB and LinTS reward &gt; StaticXGB - PASS</a:t>
+              <a:t>-  LinUCB and LinTS reward &gt;&gt; StaticXGB (p&lt;0.001, d&gt;3.4) - PASS</a:t>
             </a:r>
           </a:p>
         </p:txBody>
@@ -5470,7 +5470,7 @@
                 </a:solidFill>
                 <a:latin typeface="Calibri"/>
               </a:rPr>
-              <a:t>Why LinTS Wins</a:t>
+              <a:t>Why Uncertainty-Directed Exploration Wins</a:t>
             </a:r>
           </a:p>
         </p:txBody>
@@ -5504,7 +5504,7 @@
                 </a:solidFill>
                 <a:latin typeface="Calibri"/>
               </a:rPr>
-              <a:t>-  Thompson Sampling adapts exploration to posterior uncertainty automatically</a:t>
+              <a:t>-  LinTS and LinUCB are statistically indistinguishable (Wilcoxon p=0.87) - both win</a:t>
             </a:r>
           </a:p>
           <a:p>
@@ -5515,7 +5515,7 @@
                 </a:solidFill>
                 <a:latin typeface="Calibri"/>
               </a:rPr>
-              <a:t>-  No hyperparameter tuning of alpha needed (unlike LinUCB)</a:t>
+              <a:t>-  Uncertainty-directed exploration shrinks as posterior tightens (unlike Epsilon-Greedy)</a:t>
             </a:r>
           </a:p>
           <a:p>
@@ -5526,7 +5526,7 @@
                 </a:solidFill>
                 <a:latin typeface="Calibri"/>
               </a:rPr>
-              <a:t>-  Gaussian posterior naturally shrinks as evidence accumulates</a:t>
+              <a:t>-  LinTS needs no alpha hyperparameter (operational advantage in production)</a:t>
             </a:r>
           </a:p>
           <a:p>
@@ -5537,7 +5537,7 @@
                 </a:solidFill>
                 <a:latin typeface="Calibri"/>
               </a:rPr>
-              <a:t>-  Regret is 56% lower than LinUCB and 84% lower than Static XGB</a:t>
+              <a:t>-  Both bandits cut regret roughly in half vs. Static XGB ($21k vs $42k)</a:t>
             </a:r>
           </a:p>
         </p:txBody>
@@ -5990,7 +5990,7 @@
                 </a:solidFill>
                 <a:latin typeface="Calibri"/>
               </a:rPr>
-              <a:t>Our Result: Both Dimensions GREEN</a:t>
+              <a:t>Our Result: Within Regulatory Bounds</a:t>
             </a:r>
           </a:p>
         </p:txBody>
@@ -6024,7 +6024,7 @@
                 </a:solidFill>
                 <a:latin typeface="Calibri"/>
               </a:rPr>
-              <a:t>-  Region PSI = 0.0057  (GREEN) - no geographic bias detected</a:t>
+              <a:t>-  Region: max sliding-window PSI = 0.082 (GREEN); final PSI = 0.042 (GREEN)</a:t>
             </a:r>
           </a:p>
           <a:p>
@@ -6035,7 +6035,7 @@
                 </a:solidFill>
                 <a:latin typeface="Calibri"/>
               </a:rPr>
-              <a:t>-  Occupation PSI = 0.0095  (GREEN) - no occupational bias detected</a:t>
+              <a:t>-  Occupation: max PSI = 0.123 (low AMBER, transient); final PSI = 0.071 (GREEN)</a:t>
             </a:r>
           </a:p>
           <a:p>
@@ -6046,7 +6046,7 @@
                 </a:solidFill>
                 <a:latin typeface="Calibri"/>
               </a:rPr>
-              <a:t>-  Fairness maintained WITHOUT explicit demographic parity constraints in the reward function</a:t>
+              <a:t>-  Fairness maintained WITHOUT explicit demographic parity constraints in the reward</a:t>
             </a:r>
           </a:p>
         </p:txBody>
@@ -7695,7 +7695,7 @@
                 </a:solidFill>
                 <a:latin typeface="Calibri"/>
               </a:rPr>
-              <a:t>-  Static XGB rules underperform by 67% on cumulative reward - strong case for adaptive systems</a:t>
+              <a:t>-  Static XGB rules underperform by 25% on cumulative reward (Cohen's d=2.98) - strong case for adaptive systems</a:t>
             </a:r>
           </a:p>
           <a:p>
@@ -7849,7 +7849,7 @@
                 </a:solidFill>
                 <a:latin typeface="Calibri"/>
               </a:rPr>
-              <a:t>-  LinTS achieves lowest cumulative regret ($5,641) - 84% lower than Static XGB ($35,067)</a:t>
+              <a:t>-  LinTS and LinUCB statistically tied (p=0.87); both cut regret ~50% vs Static XGB</a:t>
             </a:r>
           </a:p>
           <a:p>
@@ -7860,7 +7860,7 @@
                 </a:solidFill>
                 <a:latin typeface="Calibri"/>
               </a:rPr>
-              <a:t>-  PSI guardrails ensure demographic fairness without degrading profitability</a:t>
+              <a:t>-  PSI guardrails and EEOC 4/5 rule both satisfied; fairness without explicit constraint</a:t>
             </a:r>
           </a:p>
           <a:p>
@@ -7871,7 +7871,7 @@
                 </a:solidFill>
                 <a:latin typeface="Calibri"/>
               </a:rPr>
-              <a:t>-  All 3 experiments pass reproducible validation (exit code 0)</a:t>
+              <a:t>-  All 4 experiments pass on 20-seed bootstrap with large effect sizes (Cohen's d &gt; 1.5)</a:t>
             </a:r>
           </a:p>
         </p:txBody>
@@ -9062,7 +9062,7 @@
                 </a:solidFill>
                 <a:latin typeface="Calibri"/>
               </a:rPr>
-              <a:t>-  Demonstrates that LinUCB and LinTS outperform static XGBoost rules by 67%+ on cumulative reward</a:t>
+              <a:t>-  Demonstrates that LinUCB and LinTS outperform static XGBoost rules by 25%+ on cumulative reward (Cohen's d = 2.98 across 20 seeds)</a:t>
             </a:r>
           </a:p>
           <a:p>

</xml_diff>